<commit_message>
Entfernung von Dopplungen, korrektur falscher werte inklusive neuerstellung von Skizzen mit verwendeten werten, vereinheitlichung von Namen
</commit_message>
<xml_diff>
--- a/Projektbericht/abbildungen/systemskizzen_layout.pptx
+++ b/Projektbericht/abbildungen/systemskizzen_layout.pptx
@@ -1595,7 +1595,7 @@
                 <a:ea typeface="Arial"/>
                 <a:cs typeface="Arial"/>
               </a:rPr>
-              <a:t>Base-Kamera</a:t>
+              <a:t>Basiskamera</a:t>
             </a:r>
           </a:p>
         </p:txBody>
@@ -2597,7 +2597,7 @@
                 <a:ea typeface="Arial"/>
                 <a:cs typeface="Arial"/>
               </a:rPr>
-              <a:t>x = -1,200 bis -0,530 m</a:t>
+              <a:t>x = -1,000 bis -0,530 m</a:t>
             </a:r>
           </a:p>
           <a:p xmlns:a="http://schemas.openxmlformats.org/drawingml/2006/main">
@@ -2620,7 +2620,7 @@
                 <a:ea typeface="Arial"/>
                 <a:cs typeface="Arial"/>
               </a:rPr>
-              <a:t>y = -0,320 bis 0,430 m</a:t>
+              <a:t>y = -0,320 bis 0,445 m</a:t>
             </a:r>
           </a:p>
         </p:txBody>
@@ -3342,7 +3342,7 @@
                 <a:ea typeface="Arial"/>
                 <a:cs typeface="Arial"/>
               </a:rPr>
-              <a:t>Base-Kamera</a:t>
+              <a:t>Basiskamera</a:t>
             </a:r>
           </a:p>
         </p:txBody>
@@ -3967,7 +3967,7 @@
                 <a:ea typeface="Arial"/>
                 <a:cs typeface="Arial"/>
               </a:rPr>
-              <a:t>untere Arbeitsraumgrenze: z = 0,309 m</a:t>
+              <a:t>untere Arbeitsraumgrenze: z = 0,299 m</a:t>
             </a:r>
           </a:p>
         </p:txBody>

</xml_diff>